<commit_message>
LTspice model built but not working.
</commit_message>
<xml_diff>
--- a/Concept design report/Week 9 - Progress Meeting.pptx
+++ b/Concept design report/Week 9 - Progress Meeting.pptx
@@ -6,8 +6,6 @@
   </p:sldMasterIdLst>
   <p:sldIdLst>
     <p:sldId id="256" r:id="rId2"/>
-    <p:sldId id="257" r:id="rId3"/>
-    <p:sldId id="258" r:id="rId4"/>
   </p:sldIdLst>
   <p:sldSz cx="12192000" cy="6858000"/>
   <p:notesSz cx="6858000" cy="9144000"/>
@@ -117,7 +115,7 @@
 <file path=ppt/revisionInfo.xml><?xml version="1.0" encoding="utf-8"?>
 <p1510:revInfo xmlns:a="http://schemas.openxmlformats.org/drawingml/2006/main" xmlns:r="http://schemas.openxmlformats.org/officeDocument/2006/relationships" xmlns:p1510="http://schemas.microsoft.com/office/powerpoint/2015/10/main">
   <p1510:revLst>
-    <p1510:client id="{9A06E4D8-8A9D-4C58-A628-439B52EB77A5}" v="1" dt="2026-08-25T09:37:04.371"/>
+    <p1510:client id="{224938E0-FFF7-45CD-B365-FCC9ADB4FBC0}" v="4" dt="2026-09-18T09:41:57.398"/>
   </p1510:revLst>
 </p1510:revInfo>
 </file>
@@ -127,18 +125,18 @@
   <pc:docChgLst>
     <pc:chgData name="Matota, LN, Miss [24989142@sun.ac.za]" userId="7a1f7bb1-56ac-4c00-937c-47b0bcb81363" providerId="ADAL" clId="{8B03531C-D65D-4FC7-A92A-A0BB20D20D7C}"/>
     <pc:docChg chg="undo custSel addSld delSld modSld">
-      <pc:chgData name="Matota, LN, Miss [24989142@sun.ac.za]" userId="7a1f7bb1-56ac-4c00-937c-47b0bcb81363" providerId="ADAL" clId="{8B03531C-D65D-4FC7-A92A-A0BB20D20D7C}" dt="2026-08-25T09:37:28.873" v="1378" actId="20577"/>
+      <pc:chgData name="Matota, LN, Miss [24989142@sun.ac.za]" userId="7a1f7bb1-56ac-4c00-937c-47b0bcb81363" providerId="ADAL" clId="{8B03531C-D65D-4FC7-A92A-A0BB20D20D7C}" dt="2026-09-18T09:42:28.391" v="2203" actId="20577"/>
       <pc:docMkLst>
         <pc:docMk/>
       </pc:docMkLst>
       <pc:sldChg chg="modSp mod">
-        <pc:chgData name="Matota, LN, Miss [24989142@sun.ac.za]" userId="7a1f7bb1-56ac-4c00-937c-47b0bcb81363" providerId="ADAL" clId="{8B03531C-D65D-4FC7-A92A-A0BB20D20D7C}" dt="2026-08-25T09:37:28.873" v="1378" actId="20577"/>
+        <pc:chgData name="Matota, LN, Miss [24989142@sun.ac.za]" userId="7a1f7bb1-56ac-4c00-937c-47b0bcb81363" providerId="ADAL" clId="{8B03531C-D65D-4FC7-A92A-A0BB20D20D7C}" dt="2026-09-18T09:42:28.391" v="2203" actId="20577"/>
         <pc:sldMkLst>
           <pc:docMk/>
           <pc:sldMk cId="3634458474" sldId="256"/>
         </pc:sldMkLst>
         <pc:spChg chg="mod">
-          <ac:chgData name="Matota, LN, Miss [24989142@sun.ac.za]" userId="7a1f7bb1-56ac-4c00-937c-47b0bcb81363" providerId="ADAL" clId="{8B03531C-D65D-4FC7-A92A-A0BB20D20D7C}" dt="2026-08-25T09:37:28.873" v="1378" actId="20577"/>
+          <ac:chgData name="Matota, LN, Miss [24989142@sun.ac.za]" userId="7a1f7bb1-56ac-4c00-937c-47b0bcb81363" providerId="ADAL" clId="{8B03531C-D65D-4FC7-A92A-A0BB20D20D7C}" dt="2026-09-18T09:35:44.891" v="1384" actId="20577"/>
           <ac:spMkLst>
             <pc:docMk/>
             <pc:sldMk cId="3634458474" sldId="256"/>
@@ -146,7 +144,7 @@
           </ac:spMkLst>
         </pc:spChg>
         <pc:spChg chg="mod">
-          <ac:chgData name="Matota, LN, Miss [24989142@sun.ac.za]" userId="7a1f7bb1-56ac-4c00-937c-47b0bcb81363" providerId="ADAL" clId="{8B03531C-D65D-4FC7-A92A-A0BB20D20D7C}" dt="2026-08-25T09:32:21.876" v="772" actId="20577"/>
+          <ac:chgData name="Matota, LN, Miss [24989142@sun.ac.za]" userId="7a1f7bb1-56ac-4c00-937c-47b0bcb81363" providerId="ADAL" clId="{8B03531C-D65D-4FC7-A92A-A0BB20D20D7C}" dt="2026-09-18T09:42:28.391" v="2203" actId="20577"/>
           <ac:spMkLst>
             <pc:docMk/>
             <pc:sldMk cId="3634458474" sldId="256"/>
@@ -154,51 +152,19 @@
           </ac:spMkLst>
         </pc:spChg>
       </pc:sldChg>
-      <pc:sldChg chg="addSp delSp modSp mod">
-        <pc:chgData name="Matota, LN, Miss [24989142@sun.ac.za]" userId="7a1f7bb1-56ac-4c00-937c-47b0bcb81363" providerId="ADAL" clId="{8B03531C-D65D-4FC7-A92A-A0BB20D20D7C}" dt="2026-08-25T09:35:29.138" v="1135" actId="20577"/>
+      <pc:sldChg chg="addSp delSp modSp del mod">
+        <pc:chgData name="Matota, LN, Miss [24989142@sun.ac.za]" userId="7a1f7bb1-56ac-4c00-937c-47b0bcb81363" providerId="ADAL" clId="{8B03531C-D65D-4FC7-A92A-A0BB20D20D7C}" dt="2026-09-18T09:35:35.755" v="1379" actId="47"/>
         <pc:sldMkLst>
           <pc:docMk/>
           <pc:sldMk cId="1867381965" sldId="257"/>
         </pc:sldMkLst>
-        <pc:spChg chg="add del mod">
-          <ac:chgData name="Matota, LN, Miss [24989142@sun.ac.za]" userId="7a1f7bb1-56ac-4c00-937c-47b0bcb81363" providerId="ADAL" clId="{8B03531C-D65D-4FC7-A92A-A0BB20D20D7C}" dt="2026-08-18T09:44:10.653" v="216" actId="20577"/>
-          <ac:spMkLst>
-            <pc:docMk/>
-            <pc:sldMk cId="1867381965" sldId="257"/>
-            <ac:spMk id="2" creationId="{3C821951-7634-C2E0-937D-C950C8DDAED8}"/>
-          </ac:spMkLst>
-        </pc:spChg>
-        <pc:spChg chg="add mod">
-          <ac:chgData name="Matota, LN, Miss [24989142@sun.ac.za]" userId="7a1f7bb1-56ac-4c00-937c-47b0bcb81363" providerId="ADAL" clId="{8B03531C-D65D-4FC7-A92A-A0BB20D20D7C}" dt="2026-08-25T09:35:29.138" v="1135" actId="20577"/>
-          <ac:spMkLst>
-            <pc:docMk/>
-            <pc:sldMk cId="1867381965" sldId="257"/>
-            <ac:spMk id="3" creationId="{2476CFE0-1662-7E01-214A-32E6B228B22E}"/>
-          </ac:spMkLst>
-        </pc:spChg>
       </pc:sldChg>
-      <pc:sldChg chg="modSp add mod">
-        <pc:chgData name="Matota, LN, Miss [24989142@sun.ac.za]" userId="7a1f7bb1-56ac-4c00-937c-47b0bcb81363" providerId="ADAL" clId="{8B03531C-D65D-4FC7-A92A-A0BB20D20D7C}" dt="2026-08-25T09:37:15.632" v="1376" actId="20577"/>
+      <pc:sldChg chg="modSp add del mod">
+        <pc:chgData name="Matota, LN, Miss [24989142@sun.ac.za]" userId="7a1f7bb1-56ac-4c00-937c-47b0bcb81363" providerId="ADAL" clId="{8B03531C-D65D-4FC7-A92A-A0BB20D20D7C}" dt="2026-09-18T09:35:37.373" v="1380" actId="47"/>
         <pc:sldMkLst>
           <pc:docMk/>
           <pc:sldMk cId="321170222" sldId="258"/>
         </pc:sldMkLst>
-        <pc:spChg chg="mod">
-          <ac:chgData name="Matota, LN, Miss [24989142@sun.ac.za]" userId="7a1f7bb1-56ac-4c00-937c-47b0bcb81363" providerId="ADAL" clId="{8B03531C-D65D-4FC7-A92A-A0BB20D20D7C}" dt="2026-08-25T09:35:44.937" v="1153" actId="20577"/>
-          <ac:spMkLst>
-            <pc:docMk/>
-            <pc:sldMk cId="321170222" sldId="258"/>
-            <ac:spMk id="2" creationId="{FC705E6B-6953-9B97-463A-66E335DE2B38}"/>
-          </ac:spMkLst>
-        </pc:spChg>
-        <pc:spChg chg="mod">
-          <ac:chgData name="Matota, LN, Miss [24989142@sun.ac.za]" userId="7a1f7bb1-56ac-4c00-937c-47b0bcb81363" providerId="ADAL" clId="{8B03531C-D65D-4FC7-A92A-A0BB20D20D7C}" dt="2026-08-25T09:37:15.632" v="1376" actId="20577"/>
-          <ac:spMkLst>
-            <pc:docMk/>
-            <pc:sldMk cId="321170222" sldId="258"/>
-            <ac:spMk id="3" creationId="{6EB54202-9793-E8F1-B053-6A5BEF0A4839}"/>
-          </ac:spMkLst>
-        </pc:spChg>
       </pc:sldChg>
     </pc:docChg>
   </pc:docChgLst>
@@ -354,7 +320,7 @@
           <a:p>
             <a:fld id="{B31332A8-CEAE-4241-9842-981792316C5A}" type="datetimeFigureOut">
               <a:rPr lang="en-ZA" smtClean="0"/>
-              <a:t>2026/08/25</a:t>
+              <a:t>2026/09/18</a:t>
             </a:fld>
             <a:endParaRPr lang="en-ZA"/>
           </a:p>
@@ -554,7 +520,7 @@
           <a:p>
             <a:fld id="{B31332A8-CEAE-4241-9842-981792316C5A}" type="datetimeFigureOut">
               <a:rPr lang="en-ZA" smtClean="0"/>
-              <a:t>2026/08/25</a:t>
+              <a:t>2026/09/18</a:t>
             </a:fld>
             <a:endParaRPr lang="en-ZA"/>
           </a:p>
@@ -764,7 +730,7 @@
           <a:p>
             <a:fld id="{B31332A8-CEAE-4241-9842-981792316C5A}" type="datetimeFigureOut">
               <a:rPr lang="en-ZA" smtClean="0"/>
-              <a:t>2026/08/25</a:t>
+              <a:t>2026/09/18</a:t>
             </a:fld>
             <a:endParaRPr lang="en-ZA"/>
           </a:p>
@@ -964,7 +930,7 @@
           <a:p>
             <a:fld id="{B31332A8-CEAE-4241-9842-981792316C5A}" type="datetimeFigureOut">
               <a:rPr lang="en-ZA" smtClean="0"/>
-              <a:t>2026/08/25</a:t>
+              <a:t>2026/09/18</a:t>
             </a:fld>
             <a:endParaRPr lang="en-ZA"/>
           </a:p>
@@ -1240,7 +1206,7 @@
           <a:p>
             <a:fld id="{B31332A8-CEAE-4241-9842-981792316C5A}" type="datetimeFigureOut">
               <a:rPr lang="en-ZA" smtClean="0"/>
-              <a:t>2026/08/25</a:t>
+              <a:t>2026/09/18</a:t>
             </a:fld>
             <a:endParaRPr lang="en-ZA"/>
           </a:p>
@@ -1508,7 +1474,7 @@
           <a:p>
             <a:fld id="{B31332A8-CEAE-4241-9842-981792316C5A}" type="datetimeFigureOut">
               <a:rPr lang="en-ZA" smtClean="0"/>
-              <a:t>2026/08/25</a:t>
+              <a:t>2026/09/18</a:t>
             </a:fld>
             <a:endParaRPr lang="en-ZA"/>
           </a:p>
@@ -1923,7 +1889,7 @@
           <a:p>
             <a:fld id="{B31332A8-CEAE-4241-9842-981792316C5A}" type="datetimeFigureOut">
               <a:rPr lang="en-ZA" smtClean="0"/>
-              <a:t>2026/08/25</a:t>
+              <a:t>2026/09/18</a:t>
             </a:fld>
             <a:endParaRPr lang="en-ZA"/>
           </a:p>
@@ -2065,7 +2031,7 @@
           <a:p>
             <a:fld id="{B31332A8-CEAE-4241-9842-981792316C5A}" type="datetimeFigureOut">
               <a:rPr lang="en-ZA" smtClean="0"/>
-              <a:t>2026/08/25</a:t>
+              <a:t>2026/09/18</a:t>
             </a:fld>
             <a:endParaRPr lang="en-ZA"/>
           </a:p>
@@ -2178,7 +2144,7 @@
           <a:p>
             <a:fld id="{B31332A8-CEAE-4241-9842-981792316C5A}" type="datetimeFigureOut">
               <a:rPr lang="en-ZA" smtClean="0"/>
-              <a:t>2026/08/25</a:t>
+              <a:t>2026/09/18</a:t>
             </a:fld>
             <a:endParaRPr lang="en-ZA"/>
           </a:p>
@@ -2491,7 +2457,7 @@
           <a:p>
             <a:fld id="{B31332A8-CEAE-4241-9842-981792316C5A}" type="datetimeFigureOut">
               <a:rPr lang="en-ZA" smtClean="0"/>
-              <a:t>2026/08/25</a:t>
+              <a:t>2026/09/18</a:t>
             </a:fld>
             <a:endParaRPr lang="en-ZA"/>
           </a:p>
@@ -2780,7 +2746,7 @@
           <a:p>
             <a:fld id="{B31332A8-CEAE-4241-9842-981792316C5A}" type="datetimeFigureOut">
               <a:rPr lang="en-ZA" smtClean="0"/>
-              <a:t>2026/08/25</a:t>
+              <a:t>2026/09/18</a:t>
             </a:fld>
             <a:endParaRPr lang="en-ZA"/>
           </a:p>
@@ -3023,7 +2989,7 @@
           <a:p>
             <a:fld id="{B31332A8-CEAE-4241-9842-981792316C5A}" type="datetimeFigureOut">
               <a:rPr lang="en-ZA" smtClean="0"/>
-              <a:t>2026/08/25</a:t>
+              <a:t>2026/09/18</a:t>
             </a:fld>
             <a:endParaRPr lang="en-ZA"/>
           </a:p>
@@ -3491,7 +3457,7 @@
                   <a:srgbClr val="C00000"/>
                 </a:solidFill>
               </a:rPr>
-              <a:t>Term 3 Week 6 – Progress Meeting</a:t>
+              <a:t>Term 4 Week 1 – Progress Meeting</a:t>
             </a:r>
             <a:endParaRPr lang="en-ZA" sz="4000" dirty="0">
               <a:solidFill>
@@ -3516,7 +3482,7 @@
         <p:spPr>
           <a:xfrm>
             <a:off x="1080977" y="1637414"/>
-            <a:ext cx="10037135" cy="1015663"/>
+            <a:ext cx="10037135" cy="3785652"/>
           </a:xfrm>
           <a:prstGeom prst="rect">
             <a:avLst/>
@@ -3537,7 +3503,7 @@
                   <a:srgbClr val="C00000"/>
                 </a:solidFill>
               </a:rPr>
-              <a:t>OVERVIEW:</a:t>
+              <a:t>General Update</a:t>
             </a:r>
           </a:p>
           <a:p>
@@ -3547,7 +3513,27 @@
             </a:pPr>
             <a:r>
               <a:rPr lang="en-US" sz="2000" dirty="0"/>
-              <a:t>Report updating</a:t>
+              <a:t>Electromagnet is almost finished in production</a:t>
+            </a:r>
+          </a:p>
+          <a:p>
+            <a:pPr marL="800100" lvl="1" indent="-342900">
+              <a:buFont typeface="Arial" panose="020B0604020202020204" pitchFamily="34" charset="0"/>
+              <a:buChar char="•"/>
+            </a:pPr>
+            <a:r>
+              <a:rPr lang="en-US" sz="2000" dirty="0"/>
+              <a:t>Pressure tabs were incorrectly welded</a:t>
+            </a:r>
+          </a:p>
+          <a:p>
+            <a:pPr marL="800100" lvl="1" indent="-342900">
+              <a:buFont typeface="Arial" panose="020B0604020202020204" pitchFamily="34" charset="0"/>
+              <a:buChar char="•"/>
+            </a:pPr>
+            <a:r>
+              <a:rPr lang="en-US" sz="2000" dirty="0"/>
+              <a:t>Expected completion is Monday</a:t>
             </a:r>
           </a:p>
           <a:p>
@@ -3557,9 +3543,91 @@
             </a:pPr>
             <a:r>
               <a:rPr lang="en-US" sz="2000" dirty="0"/>
-              <a:t>Software development</a:t>
-            </a:r>
-            <a:endParaRPr lang="en-ZA" sz="2000" dirty="0"/>
+              <a:t>Safety Report has been approved</a:t>
+            </a:r>
+          </a:p>
+          <a:p>
+            <a:pPr marL="800100" lvl="1" indent="-342900">
+              <a:buFont typeface="Arial" panose="020B0604020202020204" pitchFamily="34" charset="0"/>
+              <a:buChar char="•"/>
+            </a:pPr>
+            <a:r>
+              <a:rPr lang="en-ZA" sz="2000" dirty="0"/>
+              <a:t>Was placed in Mechatronics labs 3</a:t>
+            </a:r>
+            <a:r>
+              <a:rPr lang="en-ZA" sz="2000" baseline="30000" dirty="0"/>
+              <a:t>rd</a:t>
+            </a:r>
+            <a:r>
+              <a:rPr lang="en-ZA" sz="2000" dirty="0"/>
+              <a:t> floor</a:t>
+            </a:r>
+          </a:p>
+          <a:p>
+            <a:pPr marL="800100" lvl="1" indent="-342900">
+              <a:buFont typeface="Arial" panose="020B0604020202020204" pitchFamily="34" charset="0"/>
+              <a:buChar char="•"/>
+            </a:pPr>
+            <a:r>
+              <a:rPr lang="en-ZA" sz="2000" dirty="0"/>
+              <a:t>Was given locker to place electromagnet when not present.</a:t>
+            </a:r>
+          </a:p>
+          <a:p>
+            <a:pPr marL="800100" lvl="1" indent="-342900">
+              <a:buFont typeface="Arial" panose="020B0604020202020204" pitchFamily="34" charset="0"/>
+              <a:buChar char="•"/>
+            </a:pPr>
+            <a:r>
+              <a:rPr lang="en-ZA" sz="2000" dirty="0"/>
+              <a:t>Switching circuit and software development to be completed this </a:t>
+            </a:r>
+            <a:r>
+              <a:rPr lang="en-ZA" sz="2000" dirty="0" err="1"/>
+              <a:t>weeked</a:t>
+            </a:r>
+            <a:endParaRPr lang="en-US" sz="2000" dirty="0"/>
+          </a:p>
+          <a:p>
+            <a:pPr marL="342900" indent="-342900">
+              <a:buFont typeface="Arial" panose="020B0604020202020204" pitchFamily="34" charset="0"/>
+              <a:buChar char="•"/>
+            </a:pPr>
+            <a:r>
+              <a:rPr lang="en-US" sz="2000" dirty="0"/>
+              <a:t>Takealot Blunder</a:t>
+            </a:r>
+          </a:p>
+          <a:p>
+            <a:pPr marL="800100" lvl="1" indent="-342900">
+              <a:buFont typeface="Arial" panose="020B0604020202020204" pitchFamily="34" charset="0"/>
+              <a:buChar char="•"/>
+            </a:pPr>
+            <a:r>
+              <a:rPr lang="en-US" sz="2000" dirty="0"/>
+              <a:t>Initially, order was placed at the wrong pickup point</a:t>
+            </a:r>
+          </a:p>
+          <a:p>
+            <a:pPr marL="800100" lvl="1" indent="-342900">
+              <a:buFont typeface="Arial" panose="020B0604020202020204" pitchFamily="34" charset="0"/>
+              <a:buChar char="•"/>
+            </a:pPr>
+            <a:r>
+              <a:rPr lang="en-US" sz="2000" dirty="0"/>
+              <a:t>Error was corrected, the new delivery date is Tuesday 22/09</a:t>
+            </a:r>
+          </a:p>
+          <a:p>
+            <a:pPr marL="342900" indent="-342900">
+              <a:buFont typeface="Arial" panose="020B0604020202020204" pitchFamily="34" charset="0"/>
+              <a:buChar char="•"/>
+            </a:pPr>
+            <a:r>
+              <a:rPr lang="en-US" sz="2000" dirty="0"/>
+              <a:t>Continue documentation in report</a:t>
+            </a:r>
           </a:p>
         </p:txBody>
       </p:sp>
@@ -3567,468 +3635,6 @@
     <p:extLst>
       <p:ext uri="{BB962C8B-B14F-4D97-AF65-F5344CB8AC3E}">
         <p14:creationId xmlns:p14="http://schemas.microsoft.com/office/powerpoint/2010/main" val="3634458474"/>
-      </p:ext>
-    </p:extLst>
-  </p:cSld>
-  <p:clrMapOvr>
-    <a:masterClrMapping/>
-  </p:clrMapOvr>
-</p:sld>
-</file>
-
-<file path=ppt/slides/slide2.xml><?xml version="1.0" encoding="utf-8"?>
-<p:sld xmlns:a="http://schemas.openxmlformats.org/drawingml/2006/main" xmlns:r="http://schemas.openxmlformats.org/officeDocument/2006/relationships" xmlns:p="http://schemas.openxmlformats.org/presentationml/2006/main">
-  <p:cSld>
-    <p:bg>
-      <p:bgPr>
-        <a:blipFill dpi="0" rotWithShape="1">
-          <a:blip r:embed="rId2">
-            <a:lum/>
-          </a:blip>
-          <a:srcRect/>
-          <a:stretch>
-            <a:fillRect/>
-          </a:stretch>
-        </a:blipFill>
-        <a:effectLst/>
-      </p:bgPr>
-    </p:bg>
-    <p:spTree>
-      <p:nvGrpSpPr>
-        <p:cNvPr id="1" name="">
-          <a:extLst>
-            <a:ext uri="{FF2B5EF4-FFF2-40B4-BE49-F238E27FC236}">
-              <a16:creationId xmlns:a16="http://schemas.microsoft.com/office/drawing/2014/main" id="{D13342FF-0C5A-4368-1643-CF85BF5EE43E}"/>
-            </a:ext>
-          </a:extLst>
-        </p:cNvPr>
-        <p:cNvGrpSpPr/>
-        <p:nvPr/>
-      </p:nvGrpSpPr>
-      <p:grpSpPr>
-        <a:xfrm>
-          <a:off x="0" y="0"/>
-          <a:ext cx="0" cy="0"/>
-          <a:chOff x="0" y="0"/>
-          <a:chExt cx="0" cy="0"/>
-        </a:xfrm>
-      </p:grpSpPr>
-      <p:sp>
-        <p:nvSpPr>
-          <p:cNvPr id="2" name="TextBox 1">
-            <a:extLst>
-              <a:ext uri="{FF2B5EF4-FFF2-40B4-BE49-F238E27FC236}">
-                <a16:creationId xmlns:a16="http://schemas.microsoft.com/office/drawing/2014/main" id="{3C821951-7634-C2E0-937D-C950C8DDAED8}"/>
-              </a:ext>
-            </a:extLst>
-          </p:cNvPr>
-          <p:cNvSpPr txBox="1"/>
-          <p:nvPr/>
-        </p:nvSpPr>
-        <p:spPr>
-          <a:xfrm>
-            <a:off x="2321442" y="499731"/>
-            <a:ext cx="7549116" cy="707886"/>
-          </a:xfrm>
-          <a:prstGeom prst="rect">
-            <a:avLst/>
-          </a:prstGeom>
-          <a:solidFill>
-            <a:schemeClr val="bg1"/>
-          </a:solidFill>
-        </p:spPr>
-        <p:txBody>
-          <a:bodyPr wrap="square" rtlCol="0">
-            <a:spAutoFit/>
-          </a:bodyPr>
-          <a:lstStyle/>
-          <a:p>
-            <a:pPr algn="ctr"/>
-            <a:r>
-              <a:rPr lang="en-US" sz="4000" dirty="0">
-                <a:solidFill>
-                  <a:srgbClr val="C00000"/>
-                </a:solidFill>
-              </a:rPr>
-              <a:t>General Update</a:t>
-            </a:r>
-            <a:endParaRPr lang="en-ZA" sz="4000" dirty="0">
-              <a:solidFill>
-                <a:srgbClr val="C00000"/>
-              </a:solidFill>
-            </a:endParaRPr>
-          </a:p>
-        </p:txBody>
-      </p:sp>
-      <p:sp>
-        <p:nvSpPr>
-          <p:cNvPr id="3" name="Rectangle 2">
-            <a:extLst>
-              <a:ext uri="{FF2B5EF4-FFF2-40B4-BE49-F238E27FC236}">
-                <a16:creationId xmlns:a16="http://schemas.microsoft.com/office/drawing/2014/main" id="{2476CFE0-1662-7E01-214A-32E6B228B22E}"/>
-              </a:ext>
-            </a:extLst>
-          </p:cNvPr>
-          <p:cNvSpPr/>
-          <p:nvPr/>
-        </p:nvSpPr>
-        <p:spPr>
-          <a:xfrm>
-            <a:off x="1194390" y="2239540"/>
-            <a:ext cx="9803219" cy="2378920"/>
-          </a:xfrm>
-          <a:prstGeom prst="rect">
-            <a:avLst/>
-          </a:prstGeom>
-          <a:solidFill>
-            <a:schemeClr val="bg1"/>
-          </a:solidFill>
-          <a:ln>
-            <a:solidFill>
-              <a:schemeClr val="bg1"/>
-            </a:solidFill>
-          </a:ln>
-        </p:spPr>
-        <p:style>
-          <a:lnRef idx="2">
-            <a:schemeClr val="accent1">
-              <a:shade val="15000"/>
-            </a:schemeClr>
-          </a:lnRef>
-          <a:fillRef idx="1">
-            <a:schemeClr val="accent1"/>
-          </a:fillRef>
-          <a:effectRef idx="0">
-            <a:schemeClr val="accent1"/>
-          </a:effectRef>
-          <a:fontRef idx="minor">
-            <a:schemeClr val="lt1"/>
-          </a:fontRef>
-        </p:style>
-        <p:txBody>
-          <a:bodyPr rtlCol="0" anchor="ctr"/>
-          <a:lstStyle/>
-          <a:p>
-            <a:pPr marL="285750" indent="-285750">
-              <a:buFont typeface="Arial" panose="020B0604020202020204" pitchFamily="34" charset="0"/>
-              <a:buChar char="•"/>
-            </a:pPr>
-            <a:r>
-              <a:rPr lang="en-US" dirty="0">
-                <a:solidFill>
-                  <a:schemeClr val="tx1"/>
-                </a:solidFill>
-              </a:rPr>
-              <a:t>Introduction updated – Joint focused</a:t>
-            </a:r>
-          </a:p>
-          <a:p>
-            <a:pPr marL="285750" indent="-285750">
-              <a:buFont typeface="Arial" panose="020B0604020202020204" pitchFamily="34" charset="0"/>
-              <a:buChar char="•"/>
-            </a:pPr>
-            <a:r>
-              <a:rPr lang="en-US" dirty="0">
-                <a:solidFill>
-                  <a:schemeClr val="tx1"/>
-                </a:solidFill>
-              </a:rPr>
-              <a:t>Literature review in the process of being updated</a:t>
-            </a:r>
-          </a:p>
-          <a:p>
-            <a:pPr marL="285750" indent="-285750">
-              <a:buFont typeface="Arial" panose="020B0604020202020204" pitchFamily="34" charset="0"/>
-              <a:buChar char="•"/>
-            </a:pPr>
-            <a:r>
-              <a:rPr lang="en-US" dirty="0">
-                <a:solidFill>
-                  <a:schemeClr val="tx1"/>
-                </a:solidFill>
-              </a:rPr>
-              <a:t>Safety report still being written</a:t>
-            </a:r>
-          </a:p>
-          <a:p>
-            <a:pPr marL="285750" indent="-285750">
-              <a:buFont typeface="Arial" panose="020B0604020202020204" pitchFamily="34" charset="0"/>
-              <a:buChar char="•"/>
-            </a:pPr>
-            <a:r>
-              <a:rPr lang="en-ZA" dirty="0">
-                <a:solidFill>
-                  <a:schemeClr val="tx1"/>
-                </a:solidFill>
-              </a:rPr>
-              <a:t>Software development has begun</a:t>
-            </a:r>
-          </a:p>
-          <a:p>
-            <a:pPr marL="742950" lvl="1" indent="-285750">
-              <a:buFont typeface="Arial" panose="020B0604020202020204" pitchFamily="34" charset="0"/>
-              <a:buChar char="•"/>
-            </a:pPr>
-            <a:r>
-              <a:rPr lang="en-ZA" dirty="0">
-                <a:solidFill>
-                  <a:schemeClr val="tx1"/>
-                </a:solidFill>
-              </a:rPr>
-              <a:t>Testing a few electrical components</a:t>
-            </a:r>
-          </a:p>
-          <a:p>
-            <a:pPr marL="742950" lvl="1" indent="-285750">
-              <a:buFont typeface="Arial" panose="020B0604020202020204" pitchFamily="34" charset="0"/>
-              <a:buChar char="•"/>
-            </a:pPr>
-            <a:r>
-              <a:rPr lang="en-ZA" dirty="0">
-                <a:solidFill>
-                  <a:schemeClr val="tx1"/>
-                </a:solidFill>
-              </a:rPr>
-              <a:t>Deriving control signal for electromagnet</a:t>
-            </a:r>
-          </a:p>
-          <a:p>
-            <a:pPr marL="742950" lvl="1" indent="-285750">
-              <a:buFont typeface="Arial" panose="020B0604020202020204" pitchFamily="34" charset="0"/>
-              <a:buChar char="•"/>
-            </a:pPr>
-            <a:r>
-              <a:rPr lang="en-ZA" dirty="0">
-                <a:solidFill>
-                  <a:schemeClr val="tx1"/>
-                </a:solidFill>
-              </a:rPr>
-              <a:t>Documenting experiment report</a:t>
-            </a:r>
-          </a:p>
-        </p:txBody>
-      </p:sp>
-    </p:spTree>
-    <p:extLst>
-      <p:ext uri="{BB962C8B-B14F-4D97-AF65-F5344CB8AC3E}">
-        <p14:creationId xmlns:p14="http://schemas.microsoft.com/office/powerpoint/2010/main" val="1867381965"/>
-      </p:ext>
-    </p:extLst>
-  </p:cSld>
-  <p:clrMapOvr>
-    <a:masterClrMapping/>
-  </p:clrMapOvr>
-</p:sld>
-</file>
-
-<file path=ppt/slides/slide3.xml><?xml version="1.0" encoding="utf-8"?>
-<p:sld xmlns:a="http://schemas.openxmlformats.org/drawingml/2006/main" xmlns:r="http://schemas.openxmlformats.org/officeDocument/2006/relationships" xmlns:p="http://schemas.openxmlformats.org/presentationml/2006/main">
-  <p:cSld>
-    <p:bg>
-      <p:bgPr>
-        <a:blipFill dpi="0" rotWithShape="1">
-          <a:blip r:embed="rId2">
-            <a:lum/>
-          </a:blip>
-          <a:srcRect/>
-          <a:stretch>
-            <a:fillRect/>
-          </a:stretch>
-        </a:blipFill>
-        <a:effectLst/>
-      </p:bgPr>
-    </p:bg>
-    <p:spTree>
-      <p:nvGrpSpPr>
-        <p:cNvPr id="1" name="">
-          <a:extLst>
-            <a:ext uri="{FF2B5EF4-FFF2-40B4-BE49-F238E27FC236}">
-              <a16:creationId xmlns:a16="http://schemas.microsoft.com/office/drawing/2014/main" id="{17C5A1AE-02A7-1ED8-1F62-C23B21D49BD9}"/>
-            </a:ext>
-          </a:extLst>
-        </p:cNvPr>
-        <p:cNvGrpSpPr/>
-        <p:nvPr/>
-      </p:nvGrpSpPr>
-      <p:grpSpPr>
-        <a:xfrm>
-          <a:off x="0" y="0"/>
-          <a:ext cx="0" cy="0"/>
-          <a:chOff x="0" y="0"/>
-          <a:chExt cx="0" cy="0"/>
-        </a:xfrm>
-      </p:grpSpPr>
-      <p:sp>
-        <p:nvSpPr>
-          <p:cNvPr id="2" name="TextBox 1">
-            <a:extLst>
-              <a:ext uri="{FF2B5EF4-FFF2-40B4-BE49-F238E27FC236}">
-                <a16:creationId xmlns:a16="http://schemas.microsoft.com/office/drawing/2014/main" id="{FC705E6B-6953-9B97-463A-66E335DE2B38}"/>
-              </a:ext>
-            </a:extLst>
-          </p:cNvPr>
-          <p:cNvSpPr txBox="1"/>
-          <p:nvPr/>
-        </p:nvSpPr>
-        <p:spPr>
-          <a:xfrm>
-            <a:off x="2321442" y="499731"/>
-            <a:ext cx="7549116" cy="707886"/>
-          </a:xfrm>
-          <a:prstGeom prst="rect">
-            <a:avLst/>
-          </a:prstGeom>
-          <a:solidFill>
-            <a:schemeClr val="bg1"/>
-          </a:solidFill>
-        </p:spPr>
-        <p:txBody>
-          <a:bodyPr wrap="square" rtlCol="0">
-            <a:spAutoFit/>
-          </a:bodyPr>
-          <a:lstStyle/>
-          <a:p>
-            <a:pPr algn="ctr"/>
-            <a:r>
-              <a:rPr lang="en-US" sz="4000" dirty="0">
-                <a:solidFill>
-                  <a:srgbClr val="C00000"/>
-                </a:solidFill>
-              </a:rPr>
-              <a:t>Q&amp;A</a:t>
-            </a:r>
-            <a:endParaRPr lang="en-ZA" sz="4000" dirty="0">
-              <a:solidFill>
-                <a:srgbClr val="C00000"/>
-              </a:solidFill>
-            </a:endParaRPr>
-          </a:p>
-        </p:txBody>
-      </p:sp>
-      <p:sp>
-        <p:nvSpPr>
-          <p:cNvPr id="3" name="Rectangle 2">
-            <a:extLst>
-              <a:ext uri="{FF2B5EF4-FFF2-40B4-BE49-F238E27FC236}">
-                <a16:creationId xmlns:a16="http://schemas.microsoft.com/office/drawing/2014/main" id="{6EB54202-9793-E8F1-B053-6A5BEF0A4839}"/>
-              </a:ext>
-            </a:extLst>
-          </p:cNvPr>
-          <p:cNvSpPr/>
-          <p:nvPr/>
-        </p:nvSpPr>
-        <p:spPr>
-          <a:xfrm>
-            <a:off x="1194390" y="2239540"/>
-            <a:ext cx="9803219" cy="2378920"/>
-          </a:xfrm>
-          <a:prstGeom prst="rect">
-            <a:avLst/>
-          </a:prstGeom>
-          <a:solidFill>
-            <a:schemeClr val="bg1"/>
-          </a:solidFill>
-          <a:ln>
-            <a:solidFill>
-              <a:schemeClr val="bg1"/>
-            </a:solidFill>
-          </a:ln>
-        </p:spPr>
-        <p:style>
-          <a:lnRef idx="2">
-            <a:schemeClr val="accent1">
-              <a:shade val="15000"/>
-            </a:schemeClr>
-          </a:lnRef>
-          <a:fillRef idx="1">
-            <a:schemeClr val="accent1"/>
-          </a:fillRef>
-          <a:effectRef idx="0">
-            <a:schemeClr val="accent1"/>
-          </a:effectRef>
-          <a:fontRef idx="minor">
-            <a:schemeClr val="lt1"/>
-          </a:fontRef>
-        </p:style>
-        <p:txBody>
-          <a:bodyPr rtlCol="0" anchor="ctr"/>
-          <a:lstStyle/>
-          <a:p>
-            <a:pPr marL="285750" indent="-285750">
-              <a:buFont typeface="Arial" panose="020B0604020202020204" pitchFamily="34" charset="0"/>
-              <a:buChar char="•"/>
-            </a:pPr>
-            <a:r>
-              <a:rPr lang="en-US" dirty="0">
-                <a:solidFill>
-                  <a:schemeClr val="tx1"/>
-                </a:solidFill>
-              </a:rPr>
-              <a:t>Can extra documentation be included in the appendix?</a:t>
-            </a:r>
-          </a:p>
-          <a:p>
-            <a:pPr marL="742950" lvl="1" indent="-285750">
-              <a:buFont typeface="Arial" panose="020B0604020202020204" pitchFamily="34" charset="0"/>
-              <a:buChar char="•"/>
-            </a:pPr>
-            <a:r>
-              <a:rPr lang="en-US" dirty="0">
-                <a:solidFill>
-                  <a:schemeClr val="tx1"/>
-                </a:solidFill>
-              </a:rPr>
-              <a:t>Drawing pack</a:t>
-            </a:r>
-          </a:p>
-          <a:p>
-            <a:pPr marL="742950" lvl="1" indent="-285750">
-              <a:buFont typeface="Arial" panose="020B0604020202020204" pitchFamily="34" charset="0"/>
-              <a:buChar char="•"/>
-            </a:pPr>
-            <a:r>
-              <a:rPr lang="en-US" dirty="0">
-                <a:solidFill>
-                  <a:schemeClr val="tx1"/>
-                </a:solidFill>
-              </a:rPr>
-              <a:t>Safety report</a:t>
-            </a:r>
-          </a:p>
-          <a:p>
-            <a:pPr marL="742950" lvl="1" indent="-285750">
-              <a:buFont typeface="Arial" panose="020B0604020202020204" pitchFamily="34" charset="0"/>
-              <a:buChar char="•"/>
-            </a:pPr>
-            <a:r>
-              <a:rPr lang="en-US" dirty="0">
-                <a:solidFill>
-                  <a:schemeClr val="tx1"/>
-                </a:solidFill>
-              </a:rPr>
-              <a:t>Experimental report</a:t>
-            </a:r>
-          </a:p>
-          <a:p>
-            <a:pPr marL="285750" indent="-285750">
-              <a:buFont typeface="Arial" panose="020B0604020202020204" pitchFamily="34" charset="0"/>
-              <a:buChar char="•"/>
-            </a:pPr>
-            <a:r>
-              <a:rPr lang="en-US" dirty="0">
-                <a:solidFill>
-                  <a:schemeClr val="tx1"/>
-                </a:solidFill>
-              </a:rPr>
-              <a:t>Or this is what the portfolio is for?</a:t>
-            </a:r>
-          </a:p>
-        </p:txBody>
-      </p:sp>
-    </p:spTree>
-    <p:extLst>
-      <p:ext uri="{BB962C8B-B14F-4D97-AF65-F5344CB8AC3E}">
-        <p14:creationId xmlns:p14="http://schemas.microsoft.com/office/powerpoint/2010/main" val="321170222"/>
       </p:ext>
     </p:extLst>
   </p:cSld>

</xml_diff>

<commit_message>
Concept selection section was started.
</commit_message>
<xml_diff>
--- a/Concept design report/Week 9 - Progress Meeting.pptx
+++ b/Concept design report/Week 9 - Progress Meeting.pptx
@@ -115,7 +115,7 @@
 <file path=ppt/revisionInfo.xml><?xml version="1.0" encoding="utf-8"?>
 <p1510:revInfo xmlns:a="http://schemas.openxmlformats.org/drawingml/2006/main" xmlns:r="http://schemas.openxmlformats.org/officeDocument/2006/relationships" xmlns:p1510="http://schemas.microsoft.com/office/powerpoint/2015/10/main">
   <p1510:revLst>
-    <p1510:client id="{224938E0-FFF7-45CD-B365-FCC9ADB4FBC0}" v="4" dt="2026-09-18T09:41:57.398"/>
+    <p1510:client id="{224938E0-FFF7-45CD-B365-FCC9ADB4FBC0}" v="2" dt="2026-09-22T09:44:04.172"/>
   </p1510:revLst>
 </p1510:revInfo>
 </file>
@@ -125,18 +125,18 @@
   <pc:docChgLst>
     <pc:chgData name="Matota, LN, Miss [24989142@sun.ac.za]" userId="7a1f7bb1-56ac-4c00-937c-47b0bcb81363" providerId="ADAL" clId="{8B03531C-D65D-4FC7-A92A-A0BB20D20D7C}"/>
     <pc:docChg chg="undo custSel addSld delSld modSld">
-      <pc:chgData name="Matota, LN, Miss [24989142@sun.ac.za]" userId="7a1f7bb1-56ac-4c00-937c-47b0bcb81363" providerId="ADAL" clId="{8B03531C-D65D-4FC7-A92A-A0BB20D20D7C}" dt="2026-09-18T09:42:28.391" v="2203" actId="20577"/>
+      <pc:chgData name="Matota, LN, Miss [24989142@sun.ac.za]" userId="7a1f7bb1-56ac-4c00-937c-47b0bcb81363" providerId="ADAL" clId="{8B03531C-D65D-4FC7-A92A-A0BB20D20D7C}" dt="2026-09-22T11:57:50.970" v="2716" actId="20577"/>
       <pc:docMkLst>
         <pc:docMk/>
       </pc:docMkLst>
       <pc:sldChg chg="modSp mod">
-        <pc:chgData name="Matota, LN, Miss [24989142@sun.ac.za]" userId="7a1f7bb1-56ac-4c00-937c-47b0bcb81363" providerId="ADAL" clId="{8B03531C-D65D-4FC7-A92A-A0BB20D20D7C}" dt="2026-09-18T09:42:28.391" v="2203" actId="20577"/>
+        <pc:chgData name="Matota, LN, Miss [24989142@sun.ac.za]" userId="7a1f7bb1-56ac-4c00-937c-47b0bcb81363" providerId="ADAL" clId="{8B03531C-D65D-4FC7-A92A-A0BB20D20D7C}" dt="2026-09-22T11:57:50.970" v="2716" actId="20577"/>
         <pc:sldMkLst>
           <pc:docMk/>
           <pc:sldMk cId="3634458474" sldId="256"/>
         </pc:sldMkLst>
         <pc:spChg chg="mod">
-          <ac:chgData name="Matota, LN, Miss [24989142@sun.ac.za]" userId="7a1f7bb1-56ac-4c00-937c-47b0bcb81363" providerId="ADAL" clId="{8B03531C-D65D-4FC7-A92A-A0BB20D20D7C}" dt="2026-09-18T09:35:44.891" v="1384" actId="20577"/>
+          <ac:chgData name="Matota, LN, Miss [24989142@sun.ac.za]" userId="7a1f7bb1-56ac-4c00-937c-47b0bcb81363" providerId="ADAL" clId="{8B03531C-D65D-4FC7-A92A-A0BB20D20D7C}" dt="2026-09-22T09:40:28.712" v="2531" actId="20577"/>
           <ac:spMkLst>
             <pc:docMk/>
             <pc:sldMk cId="3634458474" sldId="256"/>
@@ -144,27 +144,13 @@
           </ac:spMkLst>
         </pc:spChg>
         <pc:spChg chg="mod">
-          <ac:chgData name="Matota, LN, Miss [24989142@sun.ac.za]" userId="7a1f7bb1-56ac-4c00-937c-47b0bcb81363" providerId="ADAL" clId="{8B03531C-D65D-4FC7-A92A-A0BB20D20D7C}" dt="2026-09-18T09:42:28.391" v="2203" actId="20577"/>
+          <ac:chgData name="Matota, LN, Miss [24989142@sun.ac.za]" userId="7a1f7bb1-56ac-4c00-937c-47b0bcb81363" providerId="ADAL" clId="{8B03531C-D65D-4FC7-A92A-A0BB20D20D7C}" dt="2026-09-22T11:57:50.970" v="2716" actId="20577"/>
           <ac:spMkLst>
             <pc:docMk/>
             <pc:sldMk cId="3634458474" sldId="256"/>
             <ac:spMk id="5" creationId="{1F8DBEAB-31A9-BA81-AEEB-213E0520AE5B}"/>
           </ac:spMkLst>
         </pc:spChg>
-      </pc:sldChg>
-      <pc:sldChg chg="addSp delSp modSp del mod">
-        <pc:chgData name="Matota, LN, Miss [24989142@sun.ac.za]" userId="7a1f7bb1-56ac-4c00-937c-47b0bcb81363" providerId="ADAL" clId="{8B03531C-D65D-4FC7-A92A-A0BB20D20D7C}" dt="2026-09-18T09:35:35.755" v="1379" actId="47"/>
-        <pc:sldMkLst>
-          <pc:docMk/>
-          <pc:sldMk cId="1867381965" sldId="257"/>
-        </pc:sldMkLst>
-      </pc:sldChg>
-      <pc:sldChg chg="modSp add del mod">
-        <pc:chgData name="Matota, LN, Miss [24989142@sun.ac.za]" userId="7a1f7bb1-56ac-4c00-937c-47b0bcb81363" providerId="ADAL" clId="{8B03531C-D65D-4FC7-A92A-A0BB20D20D7C}" dt="2026-09-18T09:35:37.373" v="1380" actId="47"/>
-        <pc:sldMkLst>
-          <pc:docMk/>
-          <pc:sldMk cId="321170222" sldId="258"/>
-        </pc:sldMkLst>
       </pc:sldChg>
     </pc:docChg>
   </pc:docChgLst>
@@ -320,7 +306,7 @@
           <a:p>
             <a:fld id="{B31332A8-CEAE-4241-9842-981792316C5A}" type="datetimeFigureOut">
               <a:rPr lang="en-ZA" smtClean="0"/>
-              <a:t>2026/09/18</a:t>
+              <a:t>2026/09/22</a:t>
             </a:fld>
             <a:endParaRPr lang="en-ZA"/>
           </a:p>
@@ -520,7 +506,7 @@
           <a:p>
             <a:fld id="{B31332A8-CEAE-4241-9842-981792316C5A}" type="datetimeFigureOut">
               <a:rPr lang="en-ZA" smtClean="0"/>
-              <a:t>2026/09/18</a:t>
+              <a:t>2026/09/22</a:t>
             </a:fld>
             <a:endParaRPr lang="en-ZA"/>
           </a:p>
@@ -730,7 +716,7 @@
           <a:p>
             <a:fld id="{B31332A8-CEAE-4241-9842-981792316C5A}" type="datetimeFigureOut">
               <a:rPr lang="en-ZA" smtClean="0"/>
-              <a:t>2026/09/18</a:t>
+              <a:t>2026/09/22</a:t>
             </a:fld>
             <a:endParaRPr lang="en-ZA"/>
           </a:p>
@@ -930,7 +916,7 @@
           <a:p>
             <a:fld id="{B31332A8-CEAE-4241-9842-981792316C5A}" type="datetimeFigureOut">
               <a:rPr lang="en-ZA" smtClean="0"/>
-              <a:t>2026/09/18</a:t>
+              <a:t>2026/09/22</a:t>
             </a:fld>
             <a:endParaRPr lang="en-ZA"/>
           </a:p>
@@ -1206,7 +1192,7 @@
           <a:p>
             <a:fld id="{B31332A8-CEAE-4241-9842-981792316C5A}" type="datetimeFigureOut">
               <a:rPr lang="en-ZA" smtClean="0"/>
-              <a:t>2026/09/18</a:t>
+              <a:t>2026/09/22</a:t>
             </a:fld>
             <a:endParaRPr lang="en-ZA"/>
           </a:p>
@@ -1474,7 +1460,7 @@
           <a:p>
             <a:fld id="{B31332A8-CEAE-4241-9842-981792316C5A}" type="datetimeFigureOut">
               <a:rPr lang="en-ZA" smtClean="0"/>
-              <a:t>2026/09/18</a:t>
+              <a:t>2026/09/22</a:t>
             </a:fld>
             <a:endParaRPr lang="en-ZA"/>
           </a:p>
@@ -1889,7 +1875,7 @@
           <a:p>
             <a:fld id="{B31332A8-CEAE-4241-9842-981792316C5A}" type="datetimeFigureOut">
               <a:rPr lang="en-ZA" smtClean="0"/>
-              <a:t>2026/09/18</a:t>
+              <a:t>2026/09/22</a:t>
             </a:fld>
             <a:endParaRPr lang="en-ZA"/>
           </a:p>
@@ -2031,7 +2017,7 @@
           <a:p>
             <a:fld id="{B31332A8-CEAE-4241-9842-981792316C5A}" type="datetimeFigureOut">
               <a:rPr lang="en-ZA" smtClean="0"/>
-              <a:t>2026/09/18</a:t>
+              <a:t>2026/09/22</a:t>
             </a:fld>
             <a:endParaRPr lang="en-ZA"/>
           </a:p>
@@ -2144,7 +2130,7 @@
           <a:p>
             <a:fld id="{B31332A8-CEAE-4241-9842-981792316C5A}" type="datetimeFigureOut">
               <a:rPr lang="en-ZA" smtClean="0"/>
-              <a:t>2026/09/18</a:t>
+              <a:t>2026/09/22</a:t>
             </a:fld>
             <a:endParaRPr lang="en-ZA"/>
           </a:p>
@@ -2457,7 +2443,7 @@
           <a:p>
             <a:fld id="{B31332A8-CEAE-4241-9842-981792316C5A}" type="datetimeFigureOut">
               <a:rPr lang="en-ZA" smtClean="0"/>
-              <a:t>2026/09/18</a:t>
+              <a:t>2026/09/22</a:t>
             </a:fld>
             <a:endParaRPr lang="en-ZA"/>
           </a:p>
@@ -2746,7 +2732,7 @@
           <a:p>
             <a:fld id="{B31332A8-CEAE-4241-9842-981792316C5A}" type="datetimeFigureOut">
               <a:rPr lang="en-ZA" smtClean="0"/>
-              <a:t>2026/09/18</a:t>
+              <a:t>2026/09/22</a:t>
             </a:fld>
             <a:endParaRPr lang="en-ZA"/>
           </a:p>
@@ -2989,7 +2975,7 @@
           <a:p>
             <a:fld id="{B31332A8-CEAE-4241-9842-981792316C5A}" type="datetimeFigureOut">
               <a:rPr lang="en-ZA" smtClean="0"/>
-              <a:t>2026/09/18</a:t>
+              <a:t>2026/09/22</a:t>
             </a:fld>
             <a:endParaRPr lang="en-ZA"/>
           </a:p>
@@ -3457,7 +3443,7 @@
                   <a:srgbClr val="C00000"/>
                 </a:solidFill>
               </a:rPr>
-              <a:t>Term 4 Week 1 – Progress Meeting</a:t>
+              <a:t>Term 4 Week 2 – Progress Meeting</a:t>
             </a:r>
             <a:endParaRPr lang="en-ZA" sz="4000" dirty="0">
               <a:solidFill>
@@ -3482,7 +3468,7 @@
         <p:spPr>
           <a:xfrm>
             <a:off x="1080977" y="1637414"/>
-            <a:ext cx="10037135" cy="3785652"/>
+            <a:ext cx="10037135" cy="3477875"/>
           </a:xfrm>
           <a:prstGeom prst="rect">
             <a:avLst/>
@@ -3513,7 +3499,21 @@
             </a:pPr>
             <a:r>
               <a:rPr lang="en-US" sz="2000" dirty="0"/>
-              <a:t>Electromagnet is almost finished in production</a:t>
+              <a:t>Electromagnet is finished in production</a:t>
+            </a:r>
+          </a:p>
+          <a:p>
+            <a:pPr marL="342900" indent="-342900">
+              <a:buFont typeface="Arial" panose="020B0604020202020204" pitchFamily="34" charset="0"/>
+              <a:buChar char="•"/>
+            </a:pPr>
+            <a:r>
+              <a:rPr lang="en-US" sz="2000"/>
+              <a:t>Takealot </a:t>
+            </a:r>
+            <a:r>
+              <a:rPr lang="en-US" sz="2000" dirty="0"/>
+              <a:t>Blunder</a:t>
             </a:r>
           </a:p>
           <a:p>
@@ -3523,7 +3523,7 @@
             </a:pPr>
             <a:r>
               <a:rPr lang="en-US" sz="2000" dirty="0"/>
-              <a:t>Pressure tabs were incorrectly welded</a:t>
+              <a:t>Waiting for collection of tape notification for today</a:t>
             </a:r>
           </a:p>
           <a:p>
@@ -3533,7 +3533,7 @@
             </a:pPr>
             <a:r>
               <a:rPr lang="en-US" sz="2000" dirty="0"/>
-              <a:t>Expected completion is Monday</a:t>
+              <a:t>Then full assembly of electromagnet can take place</a:t>
             </a:r>
           </a:p>
           <a:p>
@@ -3543,7 +3543,7 @@
             </a:pPr>
             <a:r>
               <a:rPr lang="en-US" sz="2000" dirty="0"/>
-              <a:t>Safety Report has been approved</a:t>
+              <a:t>Experiment Update</a:t>
             </a:r>
           </a:p>
           <a:p>
@@ -3552,16 +3552,8 @@
               <a:buChar char="•"/>
             </a:pPr>
             <a:r>
-              <a:rPr lang="en-ZA" sz="2000" dirty="0"/>
-              <a:t>Was placed in Mechatronics labs 3</a:t>
-            </a:r>
-            <a:r>
-              <a:rPr lang="en-ZA" sz="2000" baseline="30000" dirty="0"/>
-              <a:t>rd</a:t>
-            </a:r>
-            <a:r>
-              <a:rPr lang="en-ZA" sz="2000" dirty="0"/>
-              <a:t> floor</a:t>
+              <a:rPr lang="en-US" sz="2000" dirty="0"/>
+              <a:t>Software has been built</a:t>
             </a:r>
           </a:p>
           <a:p>
@@ -3570,8 +3562,18 @@
               <a:buChar char="•"/>
             </a:pPr>
             <a:r>
-              <a:rPr lang="en-ZA" sz="2000" dirty="0"/>
-              <a:t>Was given locker to place electromagnet when not present.</a:t>
+              <a:rPr lang="en-US" sz="2000" dirty="0"/>
+              <a:t>Switching circuit has been built, tested and is functional</a:t>
+            </a:r>
+          </a:p>
+          <a:p>
+            <a:pPr marL="342900" indent="-342900">
+              <a:buFont typeface="Arial" panose="020B0604020202020204" pitchFamily="34" charset="0"/>
+              <a:buChar char="•"/>
+            </a:pPr>
+            <a:r>
+              <a:rPr lang="en-US" sz="2000" dirty="0"/>
+              <a:t>Continue documentation in report</a:t>
             </a:r>
           </a:p>
           <a:p>
@@ -3580,14 +3582,17 @@
               <a:buChar char="•"/>
             </a:pPr>
             <a:r>
-              <a:rPr lang="en-ZA" sz="2000" dirty="0"/>
-              <a:t>Switching circuit and software development to be completed this </a:t>
-            </a:r>
-            <a:r>
-              <a:rPr lang="en-ZA" sz="2000" dirty="0" err="1"/>
-              <a:t>weeked</a:t>
-            </a:r>
-            <a:endParaRPr lang="en-US" sz="2000" dirty="0"/>
+              <a:rPr lang="en-US" sz="2000" dirty="0"/>
+              <a:t>Booked an appointment with the writing lab for the 2</a:t>
+            </a:r>
+            <a:r>
+              <a:rPr lang="en-US" sz="2000" baseline="30000" dirty="0"/>
+              <a:t>nd</a:t>
+            </a:r>
+            <a:r>
+              <a:rPr lang="en-US" sz="2000" dirty="0"/>
+              <a:t> of October</a:t>
+            </a:r>
           </a:p>
           <a:p>
             <a:pPr marL="342900" indent="-342900">
@@ -3596,37 +3601,7 @@
             </a:pPr>
             <a:r>
               <a:rPr lang="en-US" sz="2000" dirty="0"/>
-              <a:t>Takealot Blunder</a:t>
-            </a:r>
-          </a:p>
-          <a:p>
-            <a:pPr marL="800100" lvl="1" indent="-342900">
-              <a:buFont typeface="Arial" panose="020B0604020202020204" pitchFamily="34" charset="0"/>
-              <a:buChar char="•"/>
-            </a:pPr>
-            <a:r>
-              <a:rPr lang="en-US" sz="2000" dirty="0"/>
-              <a:t>Initially, order was placed at the wrong pickup point</a:t>
-            </a:r>
-          </a:p>
-          <a:p>
-            <a:pPr marL="800100" lvl="1" indent="-342900">
-              <a:buFont typeface="Arial" panose="020B0604020202020204" pitchFamily="34" charset="0"/>
-              <a:buChar char="•"/>
-            </a:pPr>
-            <a:r>
-              <a:rPr lang="en-US" sz="2000" dirty="0"/>
-              <a:t>Error was corrected, the new delivery date is Tuesday 22/09</a:t>
-            </a:r>
-          </a:p>
-          <a:p>
-            <a:pPr marL="342900" indent="-342900">
-              <a:buFont typeface="Arial" panose="020B0604020202020204" pitchFamily="34" charset="0"/>
-              <a:buChar char="•"/>
-            </a:pPr>
-            <a:r>
-              <a:rPr lang="en-US" sz="2000" dirty="0"/>
-              <a:t>Continue documentation in report</a:t>
+              <a:t>Hope to Receive approval to start experiment by Tomorrow/ Thursday latest</a:t>
             </a:r>
           </a:p>
         </p:txBody>

</xml_diff>

<commit_message>
ECSA section currently being updated.
</commit_message>
<xml_diff>
--- a/Concept design report/Week 9 - Progress Meeting.pptx
+++ b/Concept design report/Week 9 - Progress Meeting.pptx
@@ -115,7 +115,7 @@
 <file path=ppt/revisionInfo.xml><?xml version="1.0" encoding="utf-8"?>
 <p1510:revInfo xmlns:a="http://schemas.openxmlformats.org/drawingml/2006/main" xmlns:r="http://schemas.openxmlformats.org/officeDocument/2006/relationships" xmlns:p1510="http://schemas.microsoft.com/office/powerpoint/2015/10/main">
   <p1510:revLst>
-    <p1510:client id="{224938E0-FFF7-45CD-B365-FCC9ADB4FBC0}" v="2" dt="2026-09-22T09:44:04.172"/>
+    <p1510:client id="{224938E0-FFF7-45CD-B365-FCC9ADB4FBC0}" v="1" dt="2026-10-06T11:59:27.591"/>
   </p1510:revLst>
 </p1510:revInfo>
 </file>
@@ -125,18 +125,26 @@
   <pc:docChgLst>
     <pc:chgData name="Matota, LN, Miss [24989142@sun.ac.za]" userId="7a1f7bb1-56ac-4c00-937c-47b0bcb81363" providerId="ADAL" clId="{8B03531C-D65D-4FC7-A92A-A0BB20D20D7C}"/>
     <pc:docChg chg="undo custSel addSld delSld modSld">
-      <pc:chgData name="Matota, LN, Miss [24989142@sun.ac.za]" userId="7a1f7bb1-56ac-4c00-937c-47b0bcb81363" providerId="ADAL" clId="{8B03531C-D65D-4FC7-A92A-A0BB20D20D7C}" dt="2026-09-22T11:57:50.970" v="2716" actId="20577"/>
+      <pc:chgData name="Matota, LN, Miss [24989142@sun.ac.za]" userId="7a1f7bb1-56ac-4c00-937c-47b0bcb81363" providerId="ADAL" clId="{8B03531C-D65D-4FC7-A92A-A0BB20D20D7C}" dt="2026-10-06T11:59:27.591" v="2976" actId="767"/>
       <pc:docMkLst>
         <pc:docMk/>
       </pc:docMkLst>
-      <pc:sldChg chg="modSp mod">
-        <pc:chgData name="Matota, LN, Miss [24989142@sun.ac.za]" userId="7a1f7bb1-56ac-4c00-937c-47b0bcb81363" providerId="ADAL" clId="{8B03531C-D65D-4FC7-A92A-A0BB20D20D7C}" dt="2026-09-22T11:57:50.970" v="2716" actId="20577"/>
+      <pc:sldChg chg="addSp modSp mod">
+        <pc:chgData name="Matota, LN, Miss [24989142@sun.ac.za]" userId="7a1f7bb1-56ac-4c00-937c-47b0bcb81363" providerId="ADAL" clId="{8B03531C-D65D-4FC7-A92A-A0BB20D20D7C}" dt="2026-10-06T11:59:27.591" v="2976" actId="767"/>
         <pc:sldMkLst>
           <pc:docMk/>
           <pc:sldMk cId="3634458474" sldId="256"/>
         </pc:sldMkLst>
+        <pc:spChg chg="add mod">
+          <ac:chgData name="Matota, LN, Miss [24989142@sun.ac.za]" userId="7a1f7bb1-56ac-4c00-937c-47b0bcb81363" providerId="ADAL" clId="{8B03531C-D65D-4FC7-A92A-A0BB20D20D7C}" dt="2026-10-06T11:59:27.591" v="2976" actId="767"/>
+          <ac:spMkLst>
+            <pc:docMk/>
+            <pc:sldMk cId="3634458474" sldId="256"/>
+            <ac:spMk id="2" creationId="{D20B7544-B312-EF50-E49C-216D2E7AF452}"/>
+          </ac:spMkLst>
+        </pc:spChg>
         <pc:spChg chg="mod">
-          <ac:chgData name="Matota, LN, Miss [24989142@sun.ac.za]" userId="7a1f7bb1-56ac-4c00-937c-47b0bcb81363" providerId="ADAL" clId="{8B03531C-D65D-4FC7-A92A-A0BB20D20D7C}" dt="2026-09-22T09:40:28.712" v="2531" actId="20577"/>
+          <ac:chgData name="Matota, LN, Miss [24989142@sun.ac.za]" userId="7a1f7bb1-56ac-4c00-937c-47b0bcb81363" providerId="ADAL" clId="{8B03531C-D65D-4FC7-A92A-A0BB20D20D7C}" dt="2026-10-06T11:21:51.077" v="2718" actId="20577"/>
           <ac:spMkLst>
             <pc:docMk/>
             <pc:sldMk cId="3634458474" sldId="256"/>
@@ -144,7 +152,7 @@
           </ac:spMkLst>
         </pc:spChg>
         <pc:spChg chg="mod">
-          <ac:chgData name="Matota, LN, Miss [24989142@sun.ac.za]" userId="7a1f7bb1-56ac-4c00-937c-47b0bcb81363" providerId="ADAL" clId="{8B03531C-D65D-4FC7-A92A-A0BB20D20D7C}" dt="2026-09-22T11:57:50.970" v="2716" actId="20577"/>
+          <ac:chgData name="Matota, LN, Miss [24989142@sun.ac.za]" userId="7a1f7bb1-56ac-4c00-937c-47b0bcb81363" providerId="ADAL" clId="{8B03531C-D65D-4FC7-A92A-A0BB20D20D7C}" dt="2026-10-06T11:23:40.249" v="2975" actId="20577"/>
           <ac:spMkLst>
             <pc:docMk/>
             <pc:sldMk cId="3634458474" sldId="256"/>
@@ -306,7 +314,7 @@
           <a:p>
             <a:fld id="{B31332A8-CEAE-4241-9842-981792316C5A}" type="datetimeFigureOut">
               <a:rPr lang="en-ZA" smtClean="0"/>
-              <a:t>2026/09/22</a:t>
+              <a:t>2026/10/06</a:t>
             </a:fld>
             <a:endParaRPr lang="en-ZA"/>
           </a:p>
@@ -506,7 +514,7 @@
           <a:p>
             <a:fld id="{B31332A8-CEAE-4241-9842-981792316C5A}" type="datetimeFigureOut">
               <a:rPr lang="en-ZA" smtClean="0"/>
-              <a:t>2026/09/22</a:t>
+              <a:t>2026/10/06</a:t>
             </a:fld>
             <a:endParaRPr lang="en-ZA"/>
           </a:p>
@@ -716,7 +724,7 @@
           <a:p>
             <a:fld id="{B31332A8-CEAE-4241-9842-981792316C5A}" type="datetimeFigureOut">
               <a:rPr lang="en-ZA" smtClean="0"/>
-              <a:t>2026/09/22</a:t>
+              <a:t>2026/10/06</a:t>
             </a:fld>
             <a:endParaRPr lang="en-ZA"/>
           </a:p>
@@ -916,7 +924,7 @@
           <a:p>
             <a:fld id="{B31332A8-CEAE-4241-9842-981792316C5A}" type="datetimeFigureOut">
               <a:rPr lang="en-ZA" smtClean="0"/>
-              <a:t>2026/09/22</a:t>
+              <a:t>2026/10/06</a:t>
             </a:fld>
             <a:endParaRPr lang="en-ZA"/>
           </a:p>
@@ -1192,7 +1200,7 @@
           <a:p>
             <a:fld id="{B31332A8-CEAE-4241-9842-981792316C5A}" type="datetimeFigureOut">
               <a:rPr lang="en-ZA" smtClean="0"/>
-              <a:t>2026/09/22</a:t>
+              <a:t>2026/10/06</a:t>
             </a:fld>
             <a:endParaRPr lang="en-ZA"/>
           </a:p>
@@ -1460,7 +1468,7 @@
           <a:p>
             <a:fld id="{B31332A8-CEAE-4241-9842-981792316C5A}" type="datetimeFigureOut">
               <a:rPr lang="en-ZA" smtClean="0"/>
-              <a:t>2026/09/22</a:t>
+              <a:t>2026/10/06</a:t>
             </a:fld>
             <a:endParaRPr lang="en-ZA"/>
           </a:p>
@@ -1875,7 +1883,7 @@
           <a:p>
             <a:fld id="{B31332A8-CEAE-4241-9842-981792316C5A}" type="datetimeFigureOut">
               <a:rPr lang="en-ZA" smtClean="0"/>
-              <a:t>2026/09/22</a:t>
+              <a:t>2026/10/06</a:t>
             </a:fld>
             <a:endParaRPr lang="en-ZA"/>
           </a:p>
@@ -2017,7 +2025,7 @@
           <a:p>
             <a:fld id="{B31332A8-CEAE-4241-9842-981792316C5A}" type="datetimeFigureOut">
               <a:rPr lang="en-ZA" smtClean="0"/>
-              <a:t>2026/09/22</a:t>
+              <a:t>2026/10/06</a:t>
             </a:fld>
             <a:endParaRPr lang="en-ZA"/>
           </a:p>
@@ -2130,7 +2138,7 @@
           <a:p>
             <a:fld id="{B31332A8-CEAE-4241-9842-981792316C5A}" type="datetimeFigureOut">
               <a:rPr lang="en-ZA" smtClean="0"/>
-              <a:t>2026/09/22</a:t>
+              <a:t>2026/10/06</a:t>
             </a:fld>
             <a:endParaRPr lang="en-ZA"/>
           </a:p>
@@ -2443,7 +2451,7 @@
           <a:p>
             <a:fld id="{B31332A8-CEAE-4241-9842-981792316C5A}" type="datetimeFigureOut">
               <a:rPr lang="en-ZA" smtClean="0"/>
-              <a:t>2026/09/22</a:t>
+              <a:t>2026/10/06</a:t>
             </a:fld>
             <a:endParaRPr lang="en-ZA"/>
           </a:p>
@@ -2732,7 +2740,7 @@
           <a:p>
             <a:fld id="{B31332A8-CEAE-4241-9842-981792316C5A}" type="datetimeFigureOut">
               <a:rPr lang="en-ZA" smtClean="0"/>
-              <a:t>2026/09/22</a:t>
+              <a:t>2026/10/06</a:t>
             </a:fld>
             <a:endParaRPr lang="en-ZA"/>
           </a:p>
@@ -2975,7 +2983,7 @@
           <a:p>
             <a:fld id="{B31332A8-CEAE-4241-9842-981792316C5A}" type="datetimeFigureOut">
               <a:rPr lang="en-ZA" smtClean="0"/>
-              <a:t>2026/09/22</a:t>
+              <a:t>2026/10/06</a:t>
             </a:fld>
             <a:endParaRPr lang="en-ZA"/>
           </a:p>
@@ -3443,7 +3451,7 @@
                   <a:srgbClr val="C00000"/>
                 </a:solidFill>
               </a:rPr>
-              <a:t>Term 4 Week 2 – Progress Meeting</a:t>
+              <a:t>Term 4 Week 3 – Progress Meeting</a:t>
             </a:r>
             <a:endParaRPr lang="en-ZA" sz="4000" dirty="0">
               <a:solidFill>
@@ -3468,7 +3476,7 @@
         <p:spPr>
           <a:xfrm>
             <a:off x="1080977" y="1637414"/>
-            <a:ext cx="10037135" cy="3477875"/>
+            <a:ext cx="10037135" cy="1631216"/>
           </a:xfrm>
           <a:prstGeom prst="rect">
             <a:avLst/>
@@ -3499,7 +3507,7 @@
             </a:pPr>
             <a:r>
               <a:rPr lang="en-US" sz="2000" dirty="0"/>
-              <a:t>Electromagnet is finished in production</a:t>
+              <a:t>Solenoid Yoke redesign</a:t>
             </a:r>
           </a:p>
           <a:p>
@@ -3508,12 +3516,8 @@
               <a:buChar char="•"/>
             </a:pPr>
             <a:r>
-              <a:rPr lang="en-US" sz="2000"/>
-              <a:t>Takealot </a:t>
-            </a:r>
-            <a:r>
               <a:rPr lang="en-US" sz="2000" dirty="0"/>
-              <a:t>Blunder</a:t>
+              <a:t>Experimental setup should be ready be by tomorrow</a:t>
             </a:r>
           </a:p>
           <a:p>
@@ -3523,17 +3527,7 @@
             </a:pPr>
             <a:r>
               <a:rPr lang="en-US" sz="2000" dirty="0"/>
-              <a:t>Waiting for collection of tape notification for today</a:t>
-            </a:r>
-          </a:p>
-          <a:p>
-            <a:pPr marL="800100" lvl="1" indent="-342900">
-              <a:buFont typeface="Arial" panose="020B0604020202020204" pitchFamily="34" charset="0"/>
-              <a:buChar char="•"/>
-            </a:pPr>
-            <a:r>
-              <a:rPr lang="en-US" sz="2000" dirty="0"/>
-              <a:t>Then full assembly of electromagnet can take place</a:t>
+              <a:t>Will confirm for safety verification via email</a:t>
             </a:r>
           </a:p>
           <a:p>
@@ -3543,66 +3537,40 @@
             </a:pPr>
             <a:r>
               <a:rPr lang="en-US" sz="2000" dirty="0"/>
-              <a:t>Experiment Update</a:t>
-            </a:r>
-          </a:p>
-          <a:p>
-            <a:pPr marL="800100" lvl="1" indent="-342900">
-              <a:buFont typeface="Arial" panose="020B0604020202020204" pitchFamily="34" charset="0"/>
-              <a:buChar char="•"/>
-            </a:pPr>
-            <a:r>
-              <a:rPr lang="en-US" sz="2000" dirty="0"/>
-              <a:t>Software has been built</a:t>
-            </a:r>
-          </a:p>
-          <a:p>
-            <a:pPr marL="800100" lvl="1" indent="-342900">
-              <a:buFont typeface="Arial" panose="020B0604020202020204" pitchFamily="34" charset="0"/>
-              <a:buChar char="•"/>
-            </a:pPr>
-            <a:r>
-              <a:rPr lang="en-US" sz="2000" dirty="0"/>
-              <a:t>Switching circuit has been built, tested and is functional</a:t>
-            </a:r>
-          </a:p>
-          <a:p>
-            <a:pPr marL="342900" indent="-342900">
-              <a:buFont typeface="Arial" panose="020B0604020202020204" pitchFamily="34" charset="0"/>
-              <a:buChar char="•"/>
-            </a:pPr>
-            <a:r>
-              <a:rPr lang="en-US" sz="2000" dirty="0"/>
-              <a:t>Continue documentation in report</a:t>
-            </a:r>
-          </a:p>
-          <a:p>
-            <a:pPr marL="800100" lvl="1" indent="-342900">
-              <a:buFont typeface="Arial" panose="020B0604020202020204" pitchFamily="34" charset="0"/>
-              <a:buChar char="•"/>
-            </a:pPr>
-            <a:r>
-              <a:rPr lang="en-US" sz="2000" dirty="0"/>
-              <a:t>Booked an appointment with the writing lab for the 2</a:t>
-            </a:r>
-            <a:r>
-              <a:rPr lang="en-US" sz="2000" baseline="30000" dirty="0"/>
-              <a:t>nd</a:t>
-            </a:r>
-            <a:r>
-              <a:rPr lang="en-US" sz="2000" dirty="0"/>
-              <a:t> of October</a:t>
-            </a:r>
-          </a:p>
-          <a:p>
-            <a:pPr marL="342900" indent="-342900">
-              <a:buFont typeface="Arial" panose="020B0604020202020204" pitchFamily="34" charset="0"/>
-              <a:buChar char="•"/>
-            </a:pPr>
-            <a:r>
-              <a:rPr lang="en-US" sz="2000" dirty="0"/>
-              <a:t>Hope to Receive approval to start experiment by Tomorrow/ Thursday latest</a:t>
-            </a:r>
+              <a:t>Continuing with documentation</a:t>
+            </a:r>
+          </a:p>
+        </p:txBody>
+      </p:sp>
+      <p:sp>
+        <p:nvSpPr>
+          <p:cNvPr id="2" name="TextBox 1">
+            <a:extLst>
+              <a:ext uri="{FF2B5EF4-FFF2-40B4-BE49-F238E27FC236}">
+                <a16:creationId xmlns:a16="http://schemas.microsoft.com/office/drawing/2014/main" id="{D20B7544-B312-EF50-E49C-216D2E7AF452}"/>
+              </a:ext>
+            </a:extLst>
+          </p:cNvPr>
+          <p:cNvSpPr txBox="1"/>
+          <p:nvPr/>
+        </p:nvSpPr>
+        <p:spPr>
+          <a:xfrm>
+            <a:off x="2200940" y="5752214"/>
+            <a:ext cx="184731" cy="369332"/>
+          </a:xfrm>
+          <a:prstGeom prst="rect">
+            <a:avLst/>
+          </a:prstGeom>
+          <a:noFill/>
+        </p:spPr>
+        <p:txBody>
+          <a:bodyPr wrap="none" rtlCol="0">
+            <a:spAutoFit/>
+          </a:bodyPr>
+          <a:lstStyle/>
+          <a:p>
+            <a:endParaRPr lang="en-ZA" dirty="0"/>
           </a:p>
         </p:txBody>
       </p:sp>

</xml_diff>